<commit_message>
deck: fix throughput slide overflow, drop bullets, leave plot only
The throughput slides were overflowing the slide bottom because the
combined figure (figsize=(13, 7.5), height_ratios=[3,2]) rendered at
6.35" tall when placed at width=11", and the title row took 1.4",
totalling 7.75" against a 7.5" slide. The bullets text underneath then
landed on top of the bar chart at the bottom of the image.

Two fixes:
- Reduce the matplotlib figure to figsize=(14, 6.4) so the aspect ratio
  is wider/flatter (2.19 vs 1.73). At width 12.25" the rendered image
  is 5.6" tall.
- Remove the bullets entirely from every throughput slide. The plots
  carry the message on their own (lines on top, ranking bars below
  with numerical labels).

Slide layout per throughput slide: title 1.4" + image 5.6" = 7.0" used
out of 7.5" available, no overlap.
</commit_message>
<xml_diff>
--- a/results/deck/index_lock_evaluation.pptx
+++ b/results/deck/index_lock_evaluation.pptx
@@ -3366,70 +3366,14 @@
         </p:blipFill>
         <p:spPr>
           <a:xfrm>
-            <a:off x="548640" y="1280160"/>
-            <a:ext cx="10058400" cy="5767559"/>
+            <a:off x="502920" y="1371600"/>
+            <a:ext cx="11201400" cy="5091021"/>
           </a:xfrm>
           <a:prstGeom prst="rect">
             <a:avLst/>
           </a:prstGeom>
         </p:spPr>
       </p:pic>
-      <p:sp>
-        <p:nvSpPr>
-          <p:cNvPr id="5" name="TextBox 4"/>
-          <p:cNvSpPr txBox="1"/>
-          <p:nvPr/>
-        </p:nvSpPr>
-        <p:spPr>
-          <a:xfrm>
-            <a:off x="548640" y="5760720"/>
-            <a:ext cx="11064240" cy="1005840"/>
-          </a:xfrm>
-          <a:prstGeom prst="rect">
-            <a:avLst/>
-          </a:prstGeom>
-          <a:noFill/>
-        </p:spPr>
-        <p:txBody>
-          <a:bodyPr wrap="square">
-            <a:spAutoFit/>
-          </a:bodyPr>
-          <a:lstStyle/>
-          <a:p>
-            <a:pPr algn="l"/>
-            <a:r>
-              <a:rPr sz="1200" b="0">
-                <a:solidFill>
-                  <a:srgbClr val="101010"/>
-                </a:solidFill>
-              </a:rPr>
-              <a:t>   On Graviton at 8T, occ-opt finishes on top (32.3 M ops/s). tas and occ are right behind.</a:t>
-            </a:r>
-          </a:p>
-          <a:p>
-            <a:pPr algn="l"/>
-            <a:r>
-              <a:rPr sz="1200" b="0">
-                <a:solidFill>
-                  <a:srgbClr val="101010"/>
-                </a:solidFill>
-              </a:rPr>
-              <a:t>   On Xeon at 16T, ttas wins narrowly (39.0 M) with occ-opt almost tied at 38.7 M.</a:t>
-            </a:r>
-          </a:p>
-          <a:p>
-            <a:pPr algn="l"/>
-            <a:r>
-              <a:rPr sz="1200" b="0">
-                <a:solidFill>
-                  <a:srgbClr val="101010"/>
-                </a:solidFill>
-              </a:rPr>
-              <a:t>   wh-default (upstream wormhole rwlock) is in the middle of the pack on both machines.</a:t>
-            </a:r>
-          </a:p>
-        </p:txBody>
-      </p:sp>
     </p:spTree>
   </p:cSld>
   <p:clrMapOvr>
@@ -3532,70 +3476,14 @@
         </p:blipFill>
         <p:spPr>
           <a:xfrm>
-            <a:off x="548640" y="1280160"/>
-            <a:ext cx="10058400" cy="5767559"/>
+            <a:off x="502920" y="1371600"/>
+            <a:ext cx="11201400" cy="5091021"/>
           </a:xfrm>
           <a:prstGeom prst="rect">
             <a:avLst/>
           </a:prstGeom>
         </p:spPr>
       </p:pic>
-      <p:sp>
-        <p:nvSpPr>
-          <p:cNvPr id="5" name="TextBox 4"/>
-          <p:cNvSpPr txBox="1"/>
-          <p:nvPr/>
-        </p:nvSpPr>
-        <p:spPr>
-          <a:xfrm>
-            <a:off x="548640" y="5760720"/>
-            <a:ext cx="11064240" cy="1005840"/>
-          </a:xfrm>
-          <a:prstGeom prst="rect">
-            <a:avLst/>
-          </a:prstGeom>
-          <a:noFill/>
-        </p:spPr>
-        <p:txBody>
-          <a:bodyPr wrap="square">
-            <a:spAutoFit/>
-          </a:bodyPr>
-          <a:lstStyle/>
-          <a:p>
-            <a:pPr algn="l"/>
-            <a:r>
-              <a:rPr sz="1200" b="0">
-                <a:solidFill>
-                  <a:srgbClr val="101010"/>
-                </a:solidFill>
-              </a:rPr>
-              <a:t>   On Xeon, occ-opt opens a clear gap (43.9 M, vs 40.6 M for ttas at 16T).</a:t>
-            </a:r>
-          </a:p>
-          <a:p>
-            <a:pPr algn="l"/>
-            <a:r>
-              <a:rPr sz="1200" b="0">
-                <a:solidFill>
-                  <a:srgbClr val="101010"/>
-                </a:solidFill>
-              </a:rPr>
-              <a:t>   On Graviton, tas, occ-opt and ttas finish within a couple of percent at 8T.</a:t>
-            </a:r>
-          </a:p>
-          <a:p>
-            <a:pPr algn="l"/>
-            <a:r>
-              <a:rPr sz="1200" b="0">
-                <a:solidFill>
-                  <a:srgbClr val="101010"/>
-                </a:solidFill>
-              </a:rPr>
-              <a:t>   The optimistic reader is the design that benefits most from a high read percentage, especially on x86.</a:t>
-            </a:r>
-          </a:p>
-        </p:txBody>
-      </p:sp>
     </p:spTree>
   </p:cSld>
   <p:clrMapOvr>
@@ -3698,70 +3586,14 @@
         </p:blipFill>
         <p:spPr>
           <a:xfrm>
-            <a:off x="548640" y="1280160"/>
-            <a:ext cx="10058400" cy="5767559"/>
+            <a:off x="502920" y="1371600"/>
+            <a:ext cx="11201400" cy="5091021"/>
           </a:xfrm>
           <a:prstGeom prst="rect">
             <a:avLst/>
           </a:prstGeom>
         </p:spPr>
       </p:pic>
-      <p:sp>
-        <p:nvSpPr>
-          <p:cNvPr id="5" name="TextBox 4"/>
-          <p:cNvSpPr txBox="1"/>
-          <p:nvPr/>
-        </p:nvSpPr>
-        <p:spPr>
-          <a:xfrm>
-            <a:off x="548640" y="5760720"/>
-            <a:ext cx="11064240" cy="1005840"/>
-          </a:xfrm>
-          <a:prstGeom prst="rect">
-            <a:avLst/>
-          </a:prstGeom>
-          <a:noFill/>
-        </p:spPr>
-        <p:txBody>
-          <a:bodyPr wrap="square">
-            <a:spAutoFit/>
-          </a:bodyPr>
-          <a:lstStyle/>
-          <a:p>
-            <a:pPr algn="l"/>
-            <a:r>
-              <a:rPr sz="1200" b="0">
-                <a:solidFill>
-                  <a:srgbClr val="101010"/>
-                </a:solidFill>
-              </a:rPr>
-              <a:t>   On Graviton at 8T, tas, ttas and cas pull ahead (around 30 M).</a:t>
-            </a:r>
-          </a:p>
-          <a:p>
-            <a:pPr algn="l"/>
-            <a:r>
-              <a:rPr sz="1200" b="0">
-                <a:solidFill>
-                  <a:srgbClr val="101010"/>
-                </a:solidFill>
-              </a:rPr>
-              <a:t>   On Xeon at 16T, occ-opt is still on top (22.5 M) with rw and tas right next to it.</a:t>
-            </a:r>
-          </a:p>
-          <a:p>
-            <a:pPr algn="l"/>
-            <a:r>
-              <a:rPr sz="1200" b="0">
-                <a:solidFill>
-                  <a:srgbClr val="101010"/>
-                </a:solidFill>
-              </a:rPr>
-              <a:t>   Even on the workload least favourable to the optimistic path, it does not collapse.</a:t>
-            </a:r>
-          </a:p>
-        </p:txBody>
-      </p:sp>
     </p:spTree>
   </p:cSld>
   <p:clrMapOvr>
@@ -3864,70 +3696,14 @@
         </p:blipFill>
         <p:spPr>
           <a:xfrm>
-            <a:off x="548640" y="1280160"/>
-            <a:ext cx="10058400" cy="5767559"/>
+            <a:off x="502920" y="1371600"/>
+            <a:ext cx="11201400" cy="5091021"/>
           </a:xfrm>
           <a:prstGeom prst="rect">
             <a:avLst/>
           </a:prstGeom>
         </p:spPr>
       </p:pic>
-      <p:sp>
-        <p:nvSpPr>
-          <p:cNvPr id="5" name="TextBox 4"/>
-          <p:cNvSpPr txBox="1"/>
-          <p:nvPr/>
-        </p:nvSpPr>
-        <p:spPr>
-          <a:xfrm>
-            <a:off x="548640" y="5760720"/>
-            <a:ext cx="11064240" cy="1005840"/>
-          </a:xfrm>
-          <a:prstGeom prst="rect">
-            <a:avLst/>
-          </a:prstGeom>
-          <a:noFill/>
-        </p:spPr>
-        <p:txBody>
-          <a:bodyPr wrap="square">
-            <a:spAutoFit/>
-          </a:bodyPr>
-          <a:lstStyle/>
-          <a:p>
-            <a:pPr algn="l"/>
-            <a:r>
-              <a:rPr sz="1200" b="0">
-                <a:solidFill>
-                  <a:srgbClr val="101010"/>
-                </a:solidFill>
-              </a:rPr>
-              <a:t>   On Graviton at 8T, ttas wins (32.8 M) with cas right behind (32.4 M).</a:t>
-            </a:r>
-          </a:p>
-          <a:p>
-            <a:pPr algn="l"/>
-            <a:r>
-              <a:rPr sz="1200" b="0">
-                <a:solidFill>
-                  <a:srgbClr val="101010"/>
-                </a:solidFill>
-              </a:rPr>
-              <a:t>   On Xeon at 16T, tas takes the lead (18.4 M) with ttas second (16.1 M).</a:t>
-            </a:r>
-          </a:p>
-          <a:p>
-            <a:pPr algn="l"/>
-            <a:r>
-              <a:rPr sz="1200" b="0">
-                <a:solidFill>
-                  <a:srgbClr val="101010"/>
-                </a:solidFill>
-              </a:rPr>
-              <a:t>   Different best lock per architecture even on the simplest workload.</a:t>
-            </a:r>
-          </a:p>
-        </p:txBody>
-      </p:sp>
     </p:spTree>
   </p:cSld>
   <p:clrMapOvr>
@@ -4030,70 +3806,14 @@
         </p:blipFill>
         <p:spPr>
           <a:xfrm>
-            <a:off x="548640" y="1280160"/>
-            <a:ext cx="10058400" cy="5767559"/>
+            <a:off x="502920" y="1371600"/>
+            <a:ext cx="11201400" cy="5091021"/>
           </a:xfrm>
           <a:prstGeom prst="rect">
             <a:avLst/>
           </a:prstGeom>
         </p:spPr>
       </p:pic>
-      <p:sp>
-        <p:nvSpPr>
-          <p:cNvPr id="5" name="TextBox 4"/>
-          <p:cNvSpPr txBox="1"/>
-          <p:nvPr/>
-        </p:nvSpPr>
-        <p:spPr>
-          <a:xfrm>
-            <a:off x="548640" y="5760720"/>
-            <a:ext cx="11064240" cy="1005840"/>
-          </a:xfrm>
-          <a:prstGeom prst="rect">
-            <a:avLst/>
-          </a:prstGeom>
-          <a:noFill/>
-        </p:spPr>
-        <p:txBody>
-          <a:bodyPr wrap="square">
-            <a:spAutoFit/>
-          </a:bodyPr>
-          <a:lstStyle/>
-          <a:p>
-            <a:pPr algn="l"/>
-            <a:r>
-              <a:rPr sz="1200" b="0">
-                <a:solidFill>
-                  <a:srgbClr val="101010"/>
-                </a:solidFill>
-              </a:rPr>
-              <a:t>   On Graviton at 8T, tas leads (32.0 M), with std::mutex and cas tied just behind.</a:t>
-            </a:r>
-          </a:p>
-          <a:p>
-            <a:pPr algn="l"/>
-            <a:r>
-              <a:rPr sz="1200" b="0">
-                <a:solidFill>
-                  <a:srgbClr val="101010"/>
-                </a:solidFill>
-              </a:rPr>
-              <a:t>   On Xeon at 16T, cas wins (13.6 M) with ticket and tas close together.</a:t>
-            </a:r>
-          </a:p>
-          <a:p>
-            <a:pPr algn="l"/>
-            <a:r>
-              <a:rPr sz="1200" b="0">
-                <a:solidFill>
-                  <a:srgbClr val="101010"/>
-                </a:solidFill>
-              </a:rPr>
-              <a:t>   The drop from balanced to hot key on Xeon is large, which matches expectations.</a:t>
-            </a:r>
-          </a:p>
-        </p:txBody>
-      </p:sp>
     </p:spTree>
   </p:cSld>
   <p:clrMapOvr>
@@ -4196,70 +3916,14 @@
         </p:blipFill>
         <p:spPr>
           <a:xfrm>
-            <a:off x="548640" y="1280160"/>
-            <a:ext cx="10058400" cy="5767559"/>
+            <a:off x="502920" y="1371600"/>
+            <a:ext cx="11201400" cy="5091021"/>
           </a:xfrm>
           <a:prstGeom prst="rect">
             <a:avLst/>
           </a:prstGeom>
         </p:spPr>
       </p:pic>
-      <p:sp>
-        <p:nvSpPr>
-          <p:cNvPr id="5" name="TextBox 4"/>
-          <p:cNvSpPr txBox="1"/>
-          <p:nvPr/>
-        </p:nvSpPr>
-        <p:spPr>
-          <a:xfrm>
-            <a:off x="548640" y="5760720"/>
-            <a:ext cx="11064240" cy="1005840"/>
-          </a:xfrm>
-          <a:prstGeom prst="rect">
-            <a:avLst/>
-          </a:prstGeom>
-          <a:noFill/>
-        </p:spPr>
-        <p:txBody>
-          <a:bodyPr wrap="square">
-            <a:spAutoFit/>
-          </a:bodyPr>
-          <a:lstStyle/>
-          <a:p>
-            <a:pPr algn="l"/>
-            <a:r>
-              <a:rPr sz="1200" b="0">
-                <a:solidFill>
-                  <a:srgbClr val="101010"/>
-                </a:solidFill>
-              </a:rPr>
-              <a:t>   On Graviton at 8T, cas and ttas finish in a dead heat at 9.8 M.</a:t>
-            </a:r>
-          </a:p>
-          <a:p>
-            <a:pPr algn="l"/>
-            <a:r>
-              <a:rPr sz="1200" b="0">
-                <a:solidFill>
-                  <a:srgbClr val="101010"/>
-                </a:solidFill>
-              </a:rPr>
-              <a:t>   On Xeon at 16T, tas leads (13.3 M), with ttas and cas within a few percent.</a:t>
-            </a:r>
-          </a:p>
-          <a:p>
-            <a:pPr algn="l"/>
-            <a:r>
-              <a:rPr sz="1200" b="0">
-                <a:solidFill>
-                  <a:srgbClr val="101010"/>
-                </a:solidFill>
-              </a:rPr>
-              <a:t>   BronsonAVL absolute throughput is lower than StripedMap because traversal cost is real.</a:t>
-            </a:r>
-          </a:p>
-        </p:txBody>
-      </p:sp>
     </p:spTree>
   </p:cSld>
   <p:clrMapOvr>
@@ -4362,70 +4026,14 @@
         </p:blipFill>
         <p:spPr>
           <a:xfrm>
-            <a:off x="548640" y="1280160"/>
-            <a:ext cx="10058400" cy="5767559"/>
+            <a:off x="502920" y="1371600"/>
+            <a:ext cx="11201400" cy="5091021"/>
           </a:xfrm>
           <a:prstGeom prst="rect">
             <a:avLst/>
           </a:prstGeom>
         </p:spPr>
       </p:pic>
-      <p:sp>
-        <p:nvSpPr>
-          <p:cNvPr id="5" name="TextBox 4"/>
-          <p:cNvSpPr txBox="1"/>
-          <p:nvPr/>
-        </p:nvSpPr>
-        <p:spPr>
-          <a:xfrm>
-            <a:off x="548640" y="5760720"/>
-            <a:ext cx="11064240" cy="1005840"/>
-          </a:xfrm>
-          <a:prstGeom prst="rect">
-            <a:avLst/>
-          </a:prstGeom>
-          <a:noFill/>
-        </p:spPr>
-        <p:txBody>
-          <a:bodyPr wrap="square">
-            <a:spAutoFit/>
-          </a:bodyPr>
-          <a:lstStyle/>
-          <a:p>
-            <a:pPr algn="l"/>
-            <a:r>
-              <a:rPr sz="1200" b="0">
-                <a:solidFill>
-                  <a:srgbClr val="101010"/>
-                </a:solidFill>
-              </a:rPr>
-              <a:t>   On Graviton at 8T, cas takes the lead (8.6 M) with ttas and tas close behind.</a:t>
-            </a:r>
-          </a:p>
-          <a:p>
-            <a:pPr algn="l"/>
-            <a:r>
-              <a:rPr sz="1200" b="0">
-                <a:solidFill>
-                  <a:srgbClr val="101010"/>
-                </a:solidFill>
-              </a:rPr>
-              <a:t>   On Xeon at 16T, ticket wins (3.4 M), with std::mutex unusually close.</a:t>
-            </a:r>
-          </a:p>
-          <a:p>
-            <a:pPr algn="l"/>
-            <a:r>
-              <a:rPr sz="1200" b="0">
-                <a:solidFill>
-                  <a:srgbClr val="101010"/>
-                </a:solidFill>
-              </a:rPr>
-              <a:t>   Different best lock per architecture is exactly the cross arch story we wanted to surface.</a:t>
-            </a:r>
-          </a:p>
-        </p:txBody>
-      </p:sp>
     </p:spTree>
   </p:cSld>
   <p:clrMapOvr>

</xml_diff>